<commit_message>
docs: finalize TFM delivery materials
</commit_message>
<xml_diff>
--- a/docs/entrega/presentacion.pptx
+++ b/docs/entrega/presentacion.pptx
@@ -2,29 +2,29 @@
 <file path=ppt/presentation.xml><?xml version="1.0" encoding="utf-8"?>
 <p:presentation xmlns:p="http://schemas.openxmlformats.org/presentationml/2006/main">
   <p:sldMasterIdLst>
-    <p:sldMasterId xmlns:r="http://schemas.openxmlformats.org/officeDocument/2006/relationships" id="2147483648" r:id="R3c99faf22d37422b"/>
+    <p:sldMasterId xmlns:r="http://schemas.openxmlformats.org/officeDocument/2006/relationships" id="2147483648" r:id="R8715f05a33014f88"/>
   </p:sldMasterIdLst>
   <p:notesMasterIdLst>
-    <p:notesMasterId xmlns:r="http://schemas.openxmlformats.org/officeDocument/2006/relationships" r:id="Raa38d04652de4c51"/>
+    <p:notesMasterId xmlns:r="http://schemas.openxmlformats.org/officeDocument/2006/relationships" r:id="R39582323980b42a6"/>
   </p:notesMasterIdLst>
   <p:sldIdLst>
-    <p:sldId xmlns:r="http://schemas.openxmlformats.org/officeDocument/2006/relationships" id="256" r:id="Rf7df2c79cbc648e2"/>
-    <p:sldId xmlns:r="http://schemas.openxmlformats.org/officeDocument/2006/relationships" id="257" r:id="Rc450fc567e71413d"/>
-    <p:sldId xmlns:r="http://schemas.openxmlformats.org/officeDocument/2006/relationships" id="258" r:id="R4ae74236d2c646e5"/>
-    <p:sldId xmlns:r="http://schemas.openxmlformats.org/officeDocument/2006/relationships" id="259" r:id="R2020fb0f2d4e41cc"/>
-    <p:sldId xmlns:r="http://schemas.openxmlformats.org/officeDocument/2006/relationships" id="260" r:id="R10819f29170047f2"/>
-    <p:sldId xmlns:r="http://schemas.openxmlformats.org/officeDocument/2006/relationships" id="261" r:id="R119ea5bdd79b4f4d"/>
-    <p:sldId xmlns:r="http://schemas.openxmlformats.org/officeDocument/2006/relationships" id="262" r:id="R684bcfe8beb84dc7"/>
-    <p:sldId xmlns:r="http://schemas.openxmlformats.org/officeDocument/2006/relationships" id="263" r:id="Rf1178fa91c084439"/>
-    <p:sldId xmlns:r="http://schemas.openxmlformats.org/officeDocument/2006/relationships" id="264" r:id="Rd03803d01f0f4394"/>
-    <p:sldId xmlns:r="http://schemas.openxmlformats.org/officeDocument/2006/relationships" id="265" r:id="R5e65b2f5081b4ff1"/>
-    <p:sldId xmlns:r="http://schemas.openxmlformats.org/officeDocument/2006/relationships" id="266" r:id="R3b8d4d9b162d4414"/>
-    <p:sldId xmlns:r="http://schemas.openxmlformats.org/officeDocument/2006/relationships" id="267" r:id="R5e699d8fd89148b1"/>
-    <p:sldId xmlns:r="http://schemas.openxmlformats.org/officeDocument/2006/relationships" id="268" r:id="Rb841f4b136004f1f"/>
-    <p:sldId xmlns:r="http://schemas.openxmlformats.org/officeDocument/2006/relationships" id="269" r:id="Rc1c3bcf0b6684069"/>
-    <p:sldId xmlns:r="http://schemas.openxmlformats.org/officeDocument/2006/relationships" id="270" r:id="R13c6d6dd5fea48b9"/>
-    <p:sldId xmlns:r="http://schemas.openxmlformats.org/officeDocument/2006/relationships" id="271" r:id="R3084bf3946a14151"/>
-    <p:sldId xmlns:r="http://schemas.openxmlformats.org/officeDocument/2006/relationships" id="272" r:id="R017f577b68434b72"/>
+    <p:sldId xmlns:r="http://schemas.openxmlformats.org/officeDocument/2006/relationships" id="256" r:id="R77cec61bbc534f3e"/>
+    <p:sldId xmlns:r="http://schemas.openxmlformats.org/officeDocument/2006/relationships" id="257" r:id="R3bf4253ad2e344e8"/>
+    <p:sldId xmlns:r="http://schemas.openxmlformats.org/officeDocument/2006/relationships" id="258" r:id="R050e8a9ef894441e"/>
+    <p:sldId xmlns:r="http://schemas.openxmlformats.org/officeDocument/2006/relationships" id="259" r:id="R4d62e296b7af436d"/>
+    <p:sldId xmlns:r="http://schemas.openxmlformats.org/officeDocument/2006/relationships" id="260" r:id="Rf9e63fa4e2d043dd"/>
+    <p:sldId xmlns:r="http://schemas.openxmlformats.org/officeDocument/2006/relationships" id="261" r:id="Rb98143045d02478d"/>
+    <p:sldId xmlns:r="http://schemas.openxmlformats.org/officeDocument/2006/relationships" id="262" r:id="R7820bbf3b80242c8"/>
+    <p:sldId xmlns:r="http://schemas.openxmlformats.org/officeDocument/2006/relationships" id="263" r:id="R53719d50f9da4d0c"/>
+    <p:sldId xmlns:r="http://schemas.openxmlformats.org/officeDocument/2006/relationships" id="264" r:id="Rb55ba5d597944f9a"/>
+    <p:sldId xmlns:r="http://schemas.openxmlformats.org/officeDocument/2006/relationships" id="265" r:id="R2c75b6da7afd44a5"/>
+    <p:sldId xmlns:r="http://schemas.openxmlformats.org/officeDocument/2006/relationships" id="266" r:id="R0b98d3b942344293"/>
+    <p:sldId xmlns:r="http://schemas.openxmlformats.org/officeDocument/2006/relationships" id="267" r:id="R60be73fe48a9491b"/>
+    <p:sldId xmlns:r="http://schemas.openxmlformats.org/officeDocument/2006/relationships" id="268" r:id="R963900a812e94134"/>
+    <p:sldId xmlns:r="http://schemas.openxmlformats.org/officeDocument/2006/relationships" id="269" r:id="R8d43da5a330746fb"/>
+    <p:sldId xmlns:r="http://schemas.openxmlformats.org/officeDocument/2006/relationships" id="270" r:id="Rec4ab52a12be4957"/>
+    <p:sldId xmlns:r="http://schemas.openxmlformats.org/officeDocument/2006/relationships" id="271" r:id="Rb12c766e29f845fd"/>
+    <p:sldId xmlns:r="http://schemas.openxmlformats.org/officeDocument/2006/relationships" id="272" r:id="R6d7dbc1a0b9942a0"/>
   </p:sldIdLst>
   <p:sldSz cx="12192000" cy="6858000"/>
   <p:notesSz cx="6858000" cy="9144000"/>
@@ -3590,7 +3590,7 @@
   </p:cSld>
   <p:clrMap bg1="lt1" tx1="dk1" bg2="lt2" tx2="dk2" accent1="accent1" accent2="accent2" accent3="accent3" accent4="accent4" accent5="accent5" accent6="accent6" hlink="hlink" folHlink="folHlink"/>
   <p:sldLayoutIdLst>
-    <p:sldLayoutId xmlns:r="http://schemas.openxmlformats.org/officeDocument/2006/relationships" id="2147483649" r:id="Rb1304359d23540c3"/>
+    <p:sldLayoutId xmlns:r="http://schemas.openxmlformats.org/officeDocument/2006/relationships" id="2147483649" r:id="R7e84343ef2e347a5"/>
   </p:sldLayoutIdLst>
 </p:sldMaster>
 </file>
@@ -3903,7 +3903,7 @@
           <p:cNvPr id="14" name="">
             <a:extLst xmlns:a="http://schemas.openxmlformats.org/drawingml/2006/main">
               <a:ext uri="{FF2B5EF4-FFF2-40B4-BE49-F238E27FC236}">
-                <a16:creationId xmlns:a16="http://schemas.microsoft.com/office/drawing/2014/main" id="{D520546C-F216-4F13-B36C-16A036D5A6E5}"/>
+                <a16:creationId xmlns:a16="http://schemas.microsoft.com/office/drawing/2014/main" id="{629BBD2B-B64E-4574-A946-6532629F4723}"/>
               </a:ext>
             </a:extLst>
           </p:cNvPr>
@@ -3913,7 +3913,7 @@
           <p:nvPr/>
         </p:nvPicPr>
         <p:blipFill>
-          <a:blip xmlns:r="http://schemas.openxmlformats.org/officeDocument/2006/relationships" xmlns:a="http://schemas.openxmlformats.org/drawingml/2006/main" r:embed="R52ecb151348c4cb7"/>
+          <a:blip xmlns:r="http://schemas.openxmlformats.org/officeDocument/2006/relationships" xmlns:a="http://schemas.openxmlformats.org/drawingml/2006/main" r:embed="R57f834ddf1484af6"/>
           <a:stretch xmlns:a="http://schemas.openxmlformats.org/drawingml/2006/main"/>
         </p:blipFill>
         <p:spPr>
@@ -4425,7 +4425,7 @@
           <p:cNvPr id="198" name="">
             <a:extLst xmlns:a="http://schemas.openxmlformats.org/drawingml/2006/main">
               <a:ext uri="{FF2B5EF4-FFF2-40B4-BE49-F238E27FC236}">
-                <a16:creationId xmlns:a16="http://schemas.microsoft.com/office/drawing/2014/main" id="{0F7DA40F-6238-41EA-8E5C-E4124AB26867}"/>
+                <a16:creationId xmlns:a16="http://schemas.microsoft.com/office/drawing/2014/main" id="{54F924DA-500E-44A7-A291-A8E5874F9285}"/>
               </a:ext>
             </a:extLst>
           </p:cNvPr>
@@ -4435,7 +4435,7 @@
           <p:nvPr/>
         </p:nvPicPr>
         <p:blipFill>
-          <a:blip xmlns:r="http://schemas.openxmlformats.org/officeDocument/2006/relationships" xmlns:a="http://schemas.openxmlformats.org/drawingml/2006/main" r:embed="Rd6c59346e0804a27"/>
+          <a:blip xmlns:r="http://schemas.openxmlformats.org/officeDocument/2006/relationships" xmlns:a="http://schemas.openxmlformats.org/drawingml/2006/main" r:embed="Rad8d2ce63dad4efe"/>
           <a:srcRect xmlns:a="http://schemas.openxmlformats.org/drawingml/2006/main" l="0" t="10054" r="0" b="10054"/>
           <a:stretch xmlns:a="http://schemas.openxmlformats.org/drawingml/2006/main"/>
         </p:blipFill>
@@ -6359,7 +6359,7 @@
           <p:cNvPr id="229" name="">
             <a:extLst xmlns:a="http://schemas.openxmlformats.org/drawingml/2006/main">
               <a:ext uri="{FF2B5EF4-FFF2-40B4-BE49-F238E27FC236}">
-                <a16:creationId xmlns:a16="http://schemas.microsoft.com/office/drawing/2014/main" id="{C05EAE54-CF7F-4C73-AF63-61AF4D027B00}"/>
+                <a16:creationId xmlns:a16="http://schemas.microsoft.com/office/drawing/2014/main" id="{27438499-AE91-4EDD-891D-DDC2F6368E44}"/>
               </a:ext>
             </a:extLst>
           </p:cNvPr>
@@ -6369,7 +6369,7 @@
           <p:nvPr/>
         </p:nvPicPr>
         <p:blipFill>
-          <a:blip xmlns:r="http://schemas.openxmlformats.org/officeDocument/2006/relationships" xmlns:a="http://schemas.openxmlformats.org/drawingml/2006/main" r:embed="R7cc0284de23f481d"/>
+          <a:blip xmlns:r="http://schemas.openxmlformats.org/officeDocument/2006/relationships" xmlns:a="http://schemas.openxmlformats.org/drawingml/2006/main" r:embed="R560e750f103a4e4e"/>
           <a:srcRect xmlns:a="http://schemas.openxmlformats.org/drawingml/2006/main" l="0" t="10054" r="0" b="10054"/>
           <a:stretch xmlns:a="http://schemas.openxmlformats.org/drawingml/2006/main"/>
         </p:blipFill>
@@ -7783,7 +7783,7 @@
           <p:cNvPr id="250" name="">
             <a:extLst xmlns:a="http://schemas.openxmlformats.org/drawingml/2006/main">
               <a:ext uri="{FF2B5EF4-FFF2-40B4-BE49-F238E27FC236}">
-                <a16:creationId xmlns:a16="http://schemas.microsoft.com/office/drawing/2014/main" id="{AAD8033B-D425-4CDC-92B7-FCE744AD62FF}"/>
+                <a16:creationId xmlns:a16="http://schemas.microsoft.com/office/drawing/2014/main" id="{BAF51D1E-3942-4EF1-8C34-5172BC5E5069}"/>
               </a:ext>
             </a:extLst>
           </p:cNvPr>
@@ -7793,7 +7793,7 @@
           <p:nvPr/>
         </p:nvPicPr>
         <p:blipFill>
-          <a:blip xmlns:r="http://schemas.openxmlformats.org/officeDocument/2006/relationships" xmlns:a="http://schemas.openxmlformats.org/drawingml/2006/main" r:embed="R29a89fddbaff41c9"/>
+          <a:blip xmlns:r="http://schemas.openxmlformats.org/officeDocument/2006/relationships" xmlns:a="http://schemas.openxmlformats.org/drawingml/2006/main" r:embed="R176d81bdcb8e4ddd"/>
           <a:srcRect xmlns:a="http://schemas.openxmlformats.org/drawingml/2006/main" l="0" t="10054" r="0" b="10054"/>
           <a:stretch xmlns:a="http://schemas.openxmlformats.org/drawingml/2006/main"/>
         </p:blipFill>
@@ -9057,7 +9057,7 @@
           <p:cNvPr id="269" name="">
             <a:extLst xmlns:a="http://schemas.openxmlformats.org/drawingml/2006/main">
               <a:ext uri="{FF2B5EF4-FFF2-40B4-BE49-F238E27FC236}">
-                <a16:creationId xmlns:a16="http://schemas.microsoft.com/office/drawing/2014/main" id="{509A262E-ECA4-4E60-9BAC-BF197F970DF1}"/>
+                <a16:creationId xmlns:a16="http://schemas.microsoft.com/office/drawing/2014/main" id="{C9C7E90E-ACC0-4D05-AFB5-AE057F9F50DE}"/>
               </a:ext>
             </a:extLst>
           </p:cNvPr>
@@ -9067,7 +9067,7 @@
           <p:nvPr/>
         </p:nvPicPr>
         <p:blipFill>
-          <a:blip xmlns:r="http://schemas.openxmlformats.org/officeDocument/2006/relationships" xmlns:a="http://schemas.openxmlformats.org/drawingml/2006/main" r:embed="R0f146bf35fb64a35"/>
+          <a:blip xmlns:r="http://schemas.openxmlformats.org/officeDocument/2006/relationships" xmlns:a="http://schemas.openxmlformats.org/drawingml/2006/main" r:embed="Rddc5e9b97da34450"/>
           <a:srcRect xmlns:a="http://schemas.openxmlformats.org/drawingml/2006/main" l="0" t="10054" r="0" b="10054"/>
           <a:stretch xmlns:a="http://schemas.openxmlformats.org/drawingml/2006/main"/>
         </p:blipFill>
@@ -11497,7 +11497,7 @@
                 <a:ea typeface="Arial"/>
                 <a:cs typeface="Arial"/>
               </a:rPr>
-              <a:t>La ejecución conserva el hilo mediante un checkpointer y limita el número de rondas de aclaración.</a:t>
+              <a:t>MemorySaver conserva el hilo en memoria: se pierde al reiniciar y no se comparte entre réplicas.</a:t>
             </a:r>
             <a:endParaRPr sz="1350" b="0" u="none" strike="noStrike">
               <a:solidFill>
@@ -11723,7 +11723,7 @@
           <p:cNvPr id="312" name="">
             <a:extLst xmlns:a="http://schemas.openxmlformats.org/drawingml/2006/main">
               <a:ext uri="{FF2B5EF4-FFF2-40B4-BE49-F238E27FC236}">
-                <a16:creationId xmlns:a16="http://schemas.microsoft.com/office/drawing/2014/main" id="{0A4C34A0-457A-4E8D-AA7E-BB20E9F26569}"/>
+                <a16:creationId xmlns:a16="http://schemas.microsoft.com/office/drawing/2014/main" id="{531E4047-C005-4C3A-B9F9-AC1268ADE25A}"/>
               </a:ext>
             </a:extLst>
           </p:cNvPr>
@@ -11733,7 +11733,7 @@
           <p:nvPr/>
         </p:nvPicPr>
         <p:blipFill>
-          <a:blip xmlns:r="http://schemas.openxmlformats.org/officeDocument/2006/relationships" xmlns:a="http://schemas.openxmlformats.org/drawingml/2006/main" r:embed="R44035f8814b04493"/>
+          <a:blip xmlns:r="http://schemas.openxmlformats.org/officeDocument/2006/relationships" xmlns:a="http://schemas.openxmlformats.org/drawingml/2006/main" r:embed="Rfd05c5c2ac8c4354"/>
           <a:srcRect xmlns:a="http://schemas.openxmlformats.org/drawingml/2006/main" l="0" t="10054" r="0" b="10054"/>
           <a:stretch xmlns:a="http://schemas.openxmlformats.org/drawingml/2006/main"/>
         </p:blipFill>
@@ -13792,7 +13792,7 @@
           <p:cNvPr id="343" name="">
             <a:extLst xmlns:a="http://schemas.openxmlformats.org/drawingml/2006/main">
               <a:ext uri="{FF2B5EF4-FFF2-40B4-BE49-F238E27FC236}">
-                <a16:creationId xmlns:a16="http://schemas.microsoft.com/office/drawing/2014/main" id="{3DD5AE8D-3DBE-4261-9952-7032C62F6951}"/>
+                <a16:creationId xmlns:a16="http://schemas.microsoft.com/office/drawing/2014/main" id="{44669A38-9199-4B51-9B93-6145F0445E38}"/>
               </a:ext>
             </a:extLst>
           </p:cNvPr>
@@ -13802,7 +13802,7 @@
           <p:nvPr/>
         </p:nvPicPr>
         <p:blipFill>
-          <a:blip xmlns:r="http://schemas.openxmlformats.org/officeDocument/2006/relationships" xmlns:a="http://schemas.openxmlformats.org/drawingml/2006/main" r:embed="R015bf5cce3f84d37"/>
+          <a:blip xmlns:r="http://schemas.openxmlformats.org/officeDocument/2006/relationships" xmlns:a="http://schemas.openxmlformats.org/drawingml/2006/main" r:embed="R10ffb2e2bea54a8d"/>
           <a:srcRect xmlns:a="http://schemas.openxmlformats.org/drawingml/2006/main" l="0" t="10054" r="0" b="10054"/>
           <a:stretch xmlns:a="http://schemas.openxmlformats.org/drawingml/2006/main"/>
         </p:blipFill>
@@ -15818,7 +15818,7 @@
           <p:cNvPr id="375" name="">
             <a:extLst xmlns:a="http://schemas.openxmlformats.org/drawingml/2006/main">
               <a:ext uri="{FF2B5EF4-FFF2-40B4-BE49-F238E27FC236}">
-                <a16:creationId xmlns:a16="http://schemas.microsoft.com/office/drawing/2014/main" id="{7F885FE9-EA8F-4068-BA41-BC7E0EA28E90}"/>
+                <a16:creationId xmlns:a16="http://schemas.microsoft.com/office/drawing/2014/main" id="{290CBB6B-4C26-40EB-8215-40B6F6C68447}"/>
               </a:ext>
             </a:extLst>
           </p:cNvPr>
@@ -15828,7 +15828,7 @@
           <p:nvPr/>
         </p:nvPicPr>
         <p:blipFill>
-          <a:blip xmlns:r="http://schemas.openxmlformats.org/officeDocument/2006/relationships" xmlns:a="http://schemas.openxmlformats.org/drawingml/2006/main" r:embed="R702845c6d6f94d50"/>
+          <a:blip xmlns:r="http://schemas.openxmlformats.org/officeDocument/2006/relationships" xmlns:a="http://schemas.openxmlformats.org/drawingml/2006/main" r:embed="R0cbd800c99954030"/>
           <a:srcRect xmlns:a="http://schemas.openxmlformats.org/drawingml/2006/main" l="0" t="10054" r="0" b="10054"/>
           <a:stretch xmlns:a="http://schemas.openxmlformats.org/drawingml/2006/main"/>
         </p:blipFill>
@@ -16624,6 +16624,7 @@
               </a:defRPr>
             </a:defPPr>
             <a:lvl1pPr>
+              <a:buNone/>
               <a:defRPr sz="1163" b="0">
                 <a:solidFill>
                   <a:srgbClr val="FFFFFF"/>
@@ -16634,6 +16635,7 @@
               </a:defRPr>
             </a:lvl1pPr>
             <a:lvl2pPr>
+              <a:buNone/>
               <a:defRPr sz="1163" b="0">
                 <a:solidFill>
                   <a:srgbClr val="FFFFFF"/>
@@ -16644,6 +16646,7 @@
               </a:defRPr>
             </a:lvl2pPr>
             <a:lvl3pPr>
+              <a:buNone/>
               <a:defRPr sz="1163" b="0">
                 <a:solidFill>
                   <a:srgbClr val="FFFFFF"/>
@@ -16654,6 +16657,7 @@
               </a:defRPr>
             </a:lvl3pPr>
             <a:lvl4pPr>
+              <a:buNone/>
               <a:defRPr sz="1163" b="0">
                 <a:solidFill>
                   <a:srgbClr val="FFFFFF"/>
@@ -16664,6 +16668,7 @@
               </a:defRPr>
             </a:lvl4pPr>
             <a:lvl5pPr>
+              <a:buNone/>
               <a:defRPr sz="1163" b="0">
                 <a:solidFill>
                   <a:srgbClr val="FFFFFF"/>
@@ -16674,6 +16679,7 @@
               </a:defRPr>
             </a:lvl5pPr>
             <a:lvl6pPr>
+              <a:buNone/>
               <a:defRPr sz="1163" b="0">
                 <a:solidFill>
                   <a:srgbClr val="FFFFFF"/>
@@ -16684,6 +16690,7 @@
               </a:defRPr>
             </a:lvl6pPr>
             <a:lvl7pPr>
+              <a:buNone/>
               <a:defRPr sz="1163" b="0">
                 <a:solidFill>
                   <a:srgbClr val="FFFFFF"/>
@@ -16694,6 +16701,7 @@
               </a:defRPr>
             </a:lvl7pPr>
             <a:lvl8pPr>
+              <a:buNone/>
               <a:defRPr sz="1163" b="0">
                 <a:solidFill>
                   <a:srgbClr val="FFFFFF"/>
@@ -16704,6 +16712,7 @@
               </a:defRPr>
             </a:lvl8pPr>
             <a:lvl9pPr>
+              <a:buNone/>
               <a:defRPr sz="1163" b="0">
                 <a:solidFill>
                   <a:srgbClr val="FFFFFF"/>
@@ -16960,6 +16969,7 @@
               </a:defRPr>
             </a:defPPr>
             <a:lvl1pPr algn="ctr">
+              <a:buNone/>
               <a:defRPr sz="1350" b="1">
                 <a:solidFill>
                   <a:srgbClr val="FFFFFF"/>
@@ -16970,6 +16980,7 @@
               </a:defRPr>
             </a:lvl1pPr>
             <a:lvl2pPr algn="ctr">
+              <a:buNone/>
               <a:defRPr sz="1350" b="1">
                 <a:solidFill>
                   <a:srgbClr val="FFFFFF"/>
@@ -16980,6 +16991,7 @@
               </a:defRPr>
             </a:lvl2pPr>
             <a:lvl3pPr algn="ctr">
+              <a:buNone/>
               <a:defRPr sz="1350" b="1">
                 <a:solidFill>
                   <a:srgbClr val="FFFFFF"/>
@@ -16990,6 +17002,7 @@
               </a:defRPr>
             </a:lvl3pPr>
             <a:lvl4pPr algn="ctr">
+              <a:buNone/>
               <a:defRPr sz="1350" b="1">
                 <a:solidFill>
                   <a:srgbClr val="FFFFFF"/>
@@ -17000,6 +17013,7 @@
               </a:defRPr>
             </a:lvl4pPr>
             <a:lvl5pPr algn="ctr">
+              <a:buNone/>
               <a:defRPr sz="1350" b="1">
                 <a:solidFill>
                   <a:srgbClr val="FFFFFF"/>
@@ -17010,6 +17024,7 @@
               </a:defRPr>
             </a:lvl5pPr>
             <a:lvl6pPr algn="ctr">
+              <a:buNone/>
               <a:defRPr sz="1350" b="1">
                 <a:solidFill>
                   <a:srgbClr val="FFFFFF"/>
@@ -17020,6 +17035,7 @@
               </a:defRPr>
             </a:lvl6pPr>
             <a:lvl7pPr algn="ctr">
+              <a:buNone/>
               <a:defRPr sz="1350" b="1">
                 <a:solidFill>
                   <a:srgbClr val="FFFFFF"/>
@@ -17030,6 +17046,7 @@
               </a:defRPr>
             </a:lvl7pPr>
             <a:lvl8pPr algn="ctr">
+              <a:buNone/>
               <a:defRPr sz="1350" b="1">
                 <a:solidFill>
                   <a:srgbClr val="FFFFFF"/>
@@ -17040,6 +17057,7 @@
               </a:defRPr>
             </a:lvl8pPr>
             <a:lvl9pPr algn="ctr">
+              <a:buNone/>
               <a:defRPr sz="1350" b="1">
                 <a:solidFill>
                   <a:srgbClr val="FFFFFF"/>
@@ -17165,6 +17183,7 @@
               </a:defRPr>
             </a:defPPr>
             <a:lvl1pPr>
+              <a:buNone/>
               <a:defRPr sz="900" b="1">
                 <a:solidFill>
                   <a:srgbClr val="A9D4EA"/>
@@ -17175,6 +17194,7 @@
               </a:defRPr>
             </a:lvl1pPr>
             <a:lvl2pPr>
+              <a:buNone/>
               <a:defRPr sz="900" b="1">
                 <a:solidFill>
                   <a:srgbClr val="A9D4EA"/>
@@ -17185,6 +17205,7 @@
               </a:defRPr>
             </a:lvl2pPr>
             <a:lvl3pPr>
+              <a:buNone/>
               <a:defRPr sz="900" b="1">
                 <a:solidFill>
                   <a:srgbClr val="A9D4EA"/>
@@ -17195,6 +17216,7 @@
               </a:defRPr>
             </a:lvl3pPr>
             <a:lvl4pPr>
+              <a:buNone/>
               <a:defRPr sz="900" b="1">
                 <a:solidFill>
                   <a:srgbClr val="A9D4EA"/>
@@ -17205,6 +17227,7 @@
               </a:defRPr>
             </a:lvl4pPr>
             <a:lvl5pPr>
+              <a:buNone/>
               <a:defRPr sz="900" b="1">
                 <a:solidFill>
                   <a:srgbClr val="A9D4EA"/>
@@ -17215,6 +17238,7 @@
               </a:defRPr>
             </a:lvl5pPr>
             <a:lvl6pPr>
+              <a:buNone/>
               <a:defRPr sz="900" b="1">
                 <a:solidFill>
                   <a:srgbClr val="A9D4EA"/>
@@ -17225,6 +17249,7 @@
               </a:defRPr>
             </a:lvl6pPr>
             <a:lvl7pPr>
+              <a:buNone/>
               <a:defRPr sz="900" b="1">
                 <a:solidFill>
                   <a:srgbClr val="A9D4EA"/>
@@ -17235,6 +17260,7 @@
               </a:defRPr>
             </a:lvl7pPr>
             <a:lvl8pPr>
+              <a:buNone/>
               <a:defRPr sz="900" b="1">
                 <a:solidFill>
                   <a:srgbClr val="A9D4EA"/>
@@ -17245,6 +17271,7 @@
               </a:defRPr>
             </a:lvl8pPr>
             <a:lvl9pPr>
+              <a:buNone/>
               <a:defRPr sz="900" b="1">
                 <a:solidFill>
                   <a:srgbClr val="A9D4EA"/>
@@ -17409,7 +17436,7 @@
           <p:cNvPr id="375" name="">
             <a:extLst xmlns:a="http://schemas.openxmlformats.org/drawingml/2006/main">
               <a:ext uri="{FF2B5EF4-FFF2-40B4-BE49-F238E27FC236}">
-                <a16:creationId xmlns:a16="http://schemas.microsoft.com/office/drawing/2014/main" id="{7F885FE9-EA8F-4068-BA41-BC7E0EA28E90}"/>
+                <a16:creationId xmlns:a16="http://schemas.microsoft.com/office/drawing/2014/main" id="{DF59387E-8640-4919-9661-3687860A5EFD}"/>
               </a:ext>
             </a:extLst>
           </p:cNvPr>
@@ -17419,7 +17446,7 @@
           <p:nvPr/>
         </p:nvPicPr>
         <p:blipFill>
-          <a:blip xmlns:r="http://schemas.openxmlformats.org/officeDocument/2006/relationships" xmlns:a="http://schemas.openxmlformats.org/drawingml/2006/main" r:embed="Rec48f4f863964e0a"/>
+          <a:blip xmlns:r="http://schemas.openxmlformats.org/officeDocument/2006/relationships" xmlns:a="http://schemas.openxmlformats.org/drawingml/2006/main" r:embed="Rc02b3dda9fc141e6"/>
           <a:srcRect xmlns:a="http://schemas.openxmlformats.org/drawingml/2006/main" l="0" t="10054" r="0" b="10054"/>
           <a:stretch xmlns:a="http://schemas.openxmlformats.org/drawingml/2006/main"/>
         </p:blipFill>
@@ -17485,6 +17512,7 @@
               </a:defRPr>
             </a:defPPr>
             <a:lvl1pPr algn="r">
+              <a:buNone/>
               <a:defRPr sz="900" b="1">
                 <a:solidFill>
                   <a:srgbClr val="A9D4EA"/>
@@ -17495,6 +17523,7 @@
               </a:defRPr>
             </a:lvl1pPr>
             <a:lvl2pPr algn="r">
+              <a:buNone/>
               <a:defRPr sz="900" b="1">
                 <a:solidFill>
                   <a:srgbClr val="A9D4EA"/>
@@ -17505,6 +17534,7 @@
               </a:defRPr>
             </a:lvl2pPr>
             <a:lvl3pPr algn="r">
+              <a:buNone/>
               <a:defRPr sz="900" b="1">
                 <a:solidFill>
                   <a:srgbClr val="A9D4EA"/>
@@ -17515,6 +17545,7 @@
               </a:defRPr>
             </a:lvl3pPr>
             <a:lvl4pPr algn="r">
+              <a:buNone/>
               <a:defRPr sz="900" b="1">
                 <a:solidFill>
                   <a:srgbClr val="A9D4EA"/>
@@ -17525,6 +17556,7 @@
               </a:defRPr>
             </a:lvl4pPr>
             <a:lvl5pPr algn="r">
+              <a:buNone/>
               <a:defRPr sz="900" b="1">
                 <a:solidFill>
                   <a:srgbClr val="A9D4EA"/>
@@ -17535,6 +17567,7 @@
               </a:defRPr>
             </a:lvl5pPr>
             <a:lvl6pPr algn="r">
+              <a:buNone/>
               <a:defRPr sz="900" b="1">
                 <a:solidFill>
                   <a:srgbClr val="A9D4EA"/>
@@ -17545,6 +17578,7 @@
               </a:defRPr>
             </a:lvl6pPr>
             <a:lvl7pPr algn="r">
+              <a:buNone/>
               <a:defRPr sz="900" b="1">
                 <a:solidFill>
                   <a:srgbClr val="A9D4EA"/>
@@ -17555,6 +17589,7 @@
               </a:defRPr>
             </a:lvl7pPr>
             <a:lvl8pPr algn="r">
+              <a:buNone/>
               <a:defRPr sz="900" b="1">
                 <a:solidFill>
                   <a:srgbClr val="A9D4EA"/>
@@ -17565,6 +17600,7 @@
               </a:defRPr>
             </a:lvl8pPr>
             <a:lvl9pPr algn="r">
+              <a:buNone/>
               <a:defRPr sz="900" b="1">
                 <a:solidFill>
                   <a:srgbClr val="A9D4EA"/>
@@ -17661,6 +17697,7 @@
               </a:defRPr>
             </a:defPPr>
             <a:lvl1pPr>
+              <a:buNone/>
               <a:defRPr sz="3000" b="1">
                 <a:solidFill>
                   <a:srgbClr val="FFFFFF"/>
@@ -17671,6 +17708,7 @@
               </a:defRPr>
             </a:lvl1pPr>
             <a:lvl2pPr>
+              <a:buNone/>
               <a:defRPr sz="3000" b="1">
                 <a:solidFill>
                   <a:srgbClr val="FFFFFF"/>
@@ -17681,6 +17719,7 @@
               </a:defRPr>
             </a:lvl2pPr>
             <a:lvl3pPr>
+              <a:buNone/>
               <a:defRPr sz="3000" b="1">
                 <a:solidFill>
                   <a:srgbClr val="FFFFFF"/>
@@ -17691,6 +17730,7 @@
               </a:defRPr>
             </a:lvl3pPr>
             <a:lvl4pPr>
+              <a:buNone/>
               <a:defRPr sz="3000" b="1">
                 <a:solidFill>
                   <a:srgbClr val="FFFFFF"/>
@@ -17701,6 +17741,7 @@
               </a:defRPr>
             </a:lvl4pPr>
             <a:lvl5pPr>
+              <a:buNone/>
               <a:defRPr sz="3000" b="1">
                 <a:solidFill>
                   <a:srgbClr val="FFFFFF"/>
@@ -17711,6 +17752,7 @@
               </a:defRPr>
             </a:lvl5pPr>
             <a:lvl6pPr>
+              <a:buNone/>
               <a:defRPr sz="3000" b="1">
                 <a:solidFill>
                   <a:srgbClr val="FFFFFF"/>
@@ -17721,6 +17763,7 @@
               </a:defRPr>
             </a:lvl6pPr>
             <a:lvl7pPr>
+              <a:buNone/>
               <a:defRPr sz="3000" b="1">
                 <a:solidFill>
                   <a:srgbClr val="FFFFFF"/>
@@ -17731,6 +17774,7 @@
               </a:defRPr>
             </a:lvl7pPr>
             <a:lvl8pPr>
+              <a:buNone/>
               <a:defRPr sz="3000" b="1">
                 <a:solidFill>
                   <a:srgbClr val="FFFFFF"/>
@@ -17741,6 +17785,7 @@
               </a:defRPr>
             </a:lvl8pPr>
             <a:lvl9pPr>
+              <a:buNone/>
               <a:defRPr sz="3000" b="1">
                 <a:solidFill>
                   <a:srgbClr val="FFFFFF"/>
@@ -17837,6 +17882,7 @@
               </a:defRPr>
             </a:defPPr>
             <a:lvl1pPr>
+              <a:buNone/>
               <a:defRPr sz="1500">
                 <a:solidFill>
                   <a:srgbClr val="D7EAF7"/>
@@ -17847,6 +17893,7 @@
               </a:defRPr>
             </a:lvl1pPr>
             <a:lvl2pPr>
+              <a:buNone/>
               <a:defRPr sz="1500">
                 <a:solidFill>
                   <a:srgbClr val="D7EAF7"/>
@@ -17857,6 +17904,7 @@
               </a:defRPr>
             </a:lvl2pPr>
             <a:lvl3pPr>
+              <a:buNone/>
               <a:defRPr sz="1500">
                 <a:solidFill>
                   <a:srgbClr val="D7EAF7"/>
@@ -17867,6 +17915,7 @@
               </a:defRPr>
             </a:lvl3pPr>
             <a:lvl4pPr>
+              <a:buNone/>
               <a:defRPr sz="1500">
                 <a:solidFill>
                   <a:srgbClr val="D7EAF7"/>
@@ -17877,6 +17926,7 @@
               </a:defRPr>
             </a:lvl4pPr>
             <a:lvl5pPr>
+              <a:buNone/>
               <a:defRPr sz="1500">
                 <a:solidFill>
                   <a:srgbClr val="D7EAF7"/>
@@ -17887,6 +17937,7 @@
               </a:defRPr>
             </a:lvl5pPr>
             <a:lvl6pPr>
+              <a:buNone/>
               <a:defRPr sz="1500">
                 <a:solidFill>
                   <a:srgbClr val="D7EAF7"/>
@@ -17897,6 +17948,7 @@
               </a:defRPr>
             </a:lvl6pPr>
             <a:lvl7pPr>
+              <a:buNone/>
               <a:defRPr sz="1500">
                 <a:solidFill>
                   <a:srgbClr val="D7EAF7"/>
@@ -17907,6 +17959,7 @@
               </a:defRPr>
             </a:lvl7pPr>
             <a:lvl8pPr>
+              <a:buNone/>
               <a:defRPr sz="1500">
                 <a:solidFill>
                   <a:srgbClr val="D7EAF7"/>
@@ -17917,6 +17970,7 @@
               </a:defRPr>
             </a:lvl8pPr>
             <a:lvl9pPr>
+              <a:buNone/>
               <a:defRPr sz="1500">
                 <a:solidFill>
                   <a:srgbClr val="D7EAF7"/>
@@ -18013,6 +18067,7 @@
               </a:defRPr>
             </a:defPPr>
             <a:lvl1pPr>
+              <a:buNone/>
               <a:defRPr sz="1425" b="1">
                 <a:solidFill>
                   <a:srgbClr val="53C4D5"/>
@@ -18023,6 +18078,7 @@
               </a:defRPr>
             </a:lvl1pPr>
             <a:lvl2pPr>
+              <a:buNone/>
               <a:defRPr sz="1425" b="1">
                 <a:solidFill>
                   <a:srgbClr val="53C4D5"/>
@@ -18033,6 +18089,7 @@
               </a:defRPr>
             </a:lvl2pPr>
             <a:lvl3pPr>
+              <a:buNone/>
               <a:defRPr sz="1425" b="1">
                 <a:solidFill>
                   <a:srgbClr val="53C4D5"/>
@@ -18043,6 +18100,7 @@
               </a:defRPr>
             </a:lvl3pPr>
             <a:lvl4pPr>
+              <a:buNone/>
               <a:defRPr sz="1425" b="1">
                 <a:solidFill>
                   <a:srgbClr val="53C4D5"/>
@@ -18053,6 +18111,7 @@
               </a:defRPr>
             </a:lvl4pPr>
             <a:lvl5pPr>
+              <a:buNone/>
               <a:defRPr sz="1425" b="1">
                 <a:solidFill>
                   <a:srgbClr val="53C4D5"/>
@@ -18063,6 +18122,7 @@
               </a:defRPr>
             </a:lvl5pPr>
             <a:lvl6pPr>
+              <a:buNone/>
               <a:defRPr sz="1425" b="1">
                 <a:solidFill>
                   <a:srgbClr val="53C4D5"/>
@@ -18073,6 +18133,7 @@
               </a:defRPr>
             </a:lvl6pPr>
             <a:lvl7pPr>
+              <a:buNone/>
               <a:defRPr sz="1425" b="1">
                 <a:solidFill>
                   <a:srgbClr val="53C4D5"/>
@@ -18083,6 +18144,7 @@
               </a:defRPr>
             </a:lvl7pPr>
             <a:lvl8pPr>
+              <a:buNone/>
               <a:defRPr sz="1425" b="1">
                 <a:solidFill>
                   <a:srgbClr val="53C4D5"/>
@@ -18093,6 +18155,7 @@
               </a:defRPr>
             </a:lvl8pPr>
             <a:lvl9pPr>
+              <a:buNone/>
               <a:defRPr sz="1425" b="1">
                 <a:solidFill>
                   <a:srgbClr val="53C4D5"/>
@@ -18189,6 +18252,7 @@
               </a:defRPr>
             </a:defPPr>
             <a:lvl1pPr>
+              <a:buNone/>
               <a:defRPr sz="1350" b="1">
                 <a:solidFill>
                   <a:srgbClr val="FFFFFF"/>
@@ -18199,6 +18263,7 @@
               </a:defRPr>
             </a:lvl1pPr>
             <a:lvl2pPr>
+              <a:buNone/>
               <a:defRPr sz="1350" b="1">
                 <a:solidFill>
                   <a:srgbClr val="FFFFFF"/>
@@ -18209,6 +18274,7 @@
               </a:defRPr>
             </a:lvl2pPr>
             <a:lvl3pPr>
+              <a:buNone/>
               <a:defRPr sz="1350" b="1">
                 <a:solidFill>
                   <a:srgbClr val="FFFFFF"/>
@@ -18219,6 +18285,7 @@
               </a:defRPr>
             </a:lvl3pPr>
             <a:lvl4pPr>
+              <a:buNone/>
               <a:defRPr sz="1350" b="1">
                 <a:solidFill>
                   <a:srgbClr val="FFFFFF"/>
@@ -18229,6 +18296,7 @@
               </a:defRPr>
             </a:lvl4pPr>
             <a:lvl5pPr>
+              <a:buNone/>
               <a:defRPr sz="1350" b="1">
                 <a:solidFill>
                   <a:srgbClr val="FFFFFF"/>
@@ -18239,6 +18307,7 @@
               </a:defRPr>
             </a:lvl5pPr>
             <a:lvl6pPr>
+              <a:buNone/>
               <a:defRPr sz="1350" b="1">
                 <a:solidFill>
                   <a:srgbClr val="FFFFFF"/>
@@ -18249,6 +18318,7 @@
               </a:defRPr>
             </a:lvl6pPr>
             <a:lvl7pPr>
+              <a:buNone/>
               <a:defRPr sz="1350" b="1">
                 <a:solidFill>
                   <a:srgbClr val="FFFFFF"/>
@@ -18259,6 +18329,7 @@
               </a:defRPr>
             </a:lvl7pPr>
             <a:lvl8pPr>
+              <a:buNone/>
               <a:defRPr sz="1350" b="1">
                 <a:solidFill>
                   <a:srgbClr val="FFFFFF"/>
@@ -18269,6 +18340,7 @@
               </a:defRPr>
             </a:lvl8pPr>
             <a:lvl9pPr>
+              <a:buNone/>
               <a:defRPr sz="1350" b="1">
                 <a:solidFill>
                   <a:srgbClr val="FFFFFF"/>
@@ -18365,6 +18437,7 @@
               </a:defRPr>
             </a:defPPr>
             <a:lvl1pPr>
+              <a:buNone/>
               <a:defRPr sz="1425" b="1">
                 <a:solidFill>
                   <a:srgbClr val="53C4D5"/>
@@ -18375,6 +18448,7 @@
               </a:defRPr>
             </a:lvl1pPr>
             <a:lvl2pPr>
+              <a:buNone/>
               <a:defRPr sz="1425" b="1">
                 <a:solidFill>
                   <a:srgbClr val="53C4D5"/>
@@ -18385,6 +18459,7 @@
               </a:defRPr>
             </a:lvl2pPr>
             <a:lvl3pPr>
+              <a:buNone/>
               <a:defRPr sz="1425" b="1">
                 <a:solidFill>
                   <a:srgbClr val="53C4D5"/>
@@ -18395,6 +18470,7 @@
               </a:defRPr>
             </a:lvl3pPr>
             <a:lvl4pPr>
+              <a:buNone/>
               <a:defRPr sz="1425" b="1">
                 <a:solidFill>
                   <a:srgbClr val="53C4D5"/>
@@ -18405,6 +18481,7 @@
               </a:defRPr>
             </a:lvl4pPr>
             <a:lvl5pPr>
+              <a:buNone/>
               <a:defRPr sz="1425" b="1">
                 <a:solidFill>
                   <a:srgbClr val="53C4D5"/>
@@ -18415,6 +18492,7 @@
               </a:defRPr>
             </a:lvl5pPr>
             <a:lvl6pPr>
+              <a:buNone/>
               <a:defRPr sz="1425" b="1">
                 <a:solidFill>
                   <a:srgbClr val="53C4D5"/>
@@ -18425,6 +18503,7 @@
               </a:defRPr>
             </a:lvl6pPr>
             <a:lvl7pPr>
+              <a:buNone/>
               <a:defRPr sz="1425" b="1">
                 <a:solidFill>
                   <a:srgbClr val="53C4D5"/>
@@ -18435,6 +18514,7 @@
               </a:defRPr>
             </a:lvl7pPr>
             <a:lvl8pPr>
+              <a:buNone/>
               <a:defRPr sz="1425" b="1">
                 <a:solidFill>
                   <a:srgbClr val="53C4D5"/>
@@ -18445,6 +18525,7 @@
               </a:defRPr>
             </a:lvl8pPr>
             <a:lvl9pPr>
+              <a:buNone/>
               <a:defRPr sz="1425" b="1">
                 <a:solidFill>
                   <a:srgbClr val="53C4D5"/>
@@ -18541,6 +18622,7 @@
               </a:defRPr>
             </a:defPPr>
             <a:lvl1pPr>
+              <a:buNone/>
               <a:defRPr sz="1350" b="1">
                 <a:solidFill>
                   <a:srgbClr val="FFFFFF"/>
@@ -18551,6 +18633,7 @@
               </a:defRPr>
             </a:lvl1pPr>
             <a:lvl2pPr>
+              <a:buNone/>
               <a:defRPr sz="1350" b="1">
                 <a:solidFill>
                   <a:srgbClr val="FFFFFF"/>
@@ -18561,6 +18644,7 @@
               </a:defRPr>
             </a:lvl2pPr>
             <a:lvl3pPr>
+              <a:buNone/>
               <a:defRPr sz="1350" b="1">
                 <a:solidFill>
                   <a:srgbClr val="FFFFFF"/>
@@ -18571,6 +18655,7 @@
               </a:defRPr>
             </a:lvl3pPr>
             <a:lvl4pPr>
+              <a:buNone/>
               <a:defRPr sz="1350" b="1">
                 <a:solidFill>
                   <a:srgbClr val="FFFFFF"/>
@@ -18581,6 +18666,7 @@
               </a:defRPr>
             </a:lvl4pPr>
             <a:lvl5pPr>
+              <a:buNone/>
               <a:defRPr sz="1350" b="1">
                 <a:solidFill>
                   <a:srgbClr val="FFFFFF"/>
@@ -18591,6 +18677,7 @@
               </a:defRPr>
             </a:lvl5pPr>
             <a:lvl6pPr>
+              <a:buNone/>
               <a:defRPr sz="1350" b="1">
                 <a:solidFill>
                   <a:srgbClr val="FFFFFF"/>
@@ -18601,6 +18688,7 @@
               </a:defRPr>
             </a:lvl6pPr>
             <a:lvl7pPr>
+              <a:buNone/>
               <a:defRPr sz="1350" b="1">
                 <a:solidFill>
                   <a:srgbClr val="FFFFFF"/>
@@ -18611,6 +18699,7 @@
               </a:defRPr>
             </a:lvl7pPr>
             <a:lvl8pPr>
+              <a:buNone/>
               <a:defRPr sz="1350" b="1">
                 <a:solidFill>
                   <a:srgbClr val="FFFFFF"/>
@@ -18621,6 +18710,7 @@
               </a:defRPr>
             </a:lvl8pPr>
             <a:lvl9pPr>
+              <a:buNone/>
               <a:defRPr sz="1350" b="1">
                 <a:solidFill>
                   <a:srgbClr val="FFFFFF"/>
@@ -18717,6 +18807,7 @@
               </a:defRPr>
             </a:defPPr>
             <a:lvl1pPr>
+              <a:buNone/>
               <a:defRPr sz="1425" b="1">
                 <a:solidFill>
                   <a:srgbClr val="53C4D5"/>
@@ -18727,6 +18818,7 @@
               </a:defRPr>
             </a:lvl1pPr>
             <a:lvl2pPr>
+              <a:buNone/>
               <a:defRPr sz="1425" b="1">
                 <a:solidFill>
                   <a:srgbClr val="53C4D5"/>
@@ -18737,6 +18829,7 @@
               </a:defRPr>
             </a:lvl2pPr>
             <a:lvl3pPr>
+              <a:buNone/>
               <a:defRPr sz="1425" b="1">
                 <a:solidFill>
                   <a:srgbClr val="53C4D5"/>
@@ -18747,6 +18840,7 @@
               </a:defRPr>
             </a:lvl3pPr>
             <a:lvl4pPr>
+              <a:buNone/>
               <a:defRPr sz="1425" b="1">
                 <a:solidFill>
                   <a:srgbClr val="53C4D5"/>
@@ -18757,6 +18851,7 @@
               </a:defRPr>
             </a:lvl4pPr>
             <a:lvl5pPr>
+              <a:buNone/>
               <a:defRPr sz="1425" b="1">
                 <a:solidFill>
                   <a:srgbClr val="53C4D5"/>
@@ -18767,6 +18862,7 @@
               </a:defRPr>
             </a:lvl5pPr>
             <a:lvl6pPr>
+              <a:buNone/>
               <a:defRPr sz="1425" b="1">
                 <a:solidFill>
                   <a:srgbClr val="53C4D5"/>
@@ -18777,6 +18873,7 @@
               </a:defRPr>
             </a:lvl6pPr>
             <a:lvl7pPr>
+              <a:buNone/>
               <a:defRPr sz="1425" b="1">
                 <a:solidFill>
                   <a:srgbClr val="53C4D5"/>
@@ -18787,6 +18884,7 @@
               </a:defRPr>
             </a:lvl7pPr>
             <a:lvl8pPr>
+              <a:buNone/>
               <a:defRPr sz="1425" b="1">
                 <a:solidFill>
                   <a:srgbClr val="53C4D5"/>
@@ -18797,6 +18895,7 @@
               </a:defRPr>
             </a:lvl8pPr>
             <a:lvl9pPr>
+              <a:buNone/>
               <a:defRPr sz="1425" b="1">
                 <a:solidFill>
                   <a:srgbClr val="53C4D5"/>
@@ -18893,6 +18992,7 @@
               </a:defRPr>
             </a:defPPr>
             <a:lvl1pPr>
+              <a:buNone/>
               <a:defRPr sz="1350" b="1">
                 <a:solidFill>
                   <a:srgbClr val="FFFFFF"/>
@@ -18903,6 +19003,7 @@
               </a:defRPr>
             </a:lvl1pPr>
             <a:lvl2pPr>
+              <a:buNone/>
               <a:defRPr sz="1350" b="1">
                 <a:solidFill>
                   <a:srgbClr val="FFFFFF"/>
@@ -18913,6 +19014,7 @@
               </a:defRPr>
             </a:lvl2pPr>
             <a:lvl3pPr>
+              <a:buNone/>
               <a:defRPr sz="1350" b="1">
                 <a:solidFill>
                   <a:srgbClr val="FFFFFF"/>
@@ -18923,6 +19025,7 @@
               </a:defRPr>
             </a:lvl3pPr>
             <a:lvl4pPr>
+              <a:buNone/>
               <a:defRPr sz="1350" b="1">
                 <a:solidFill>
                   <a:srgbClr val="FFFFFF"/>
@@ -18933,6 +19036,7 @@
               </a:defRPr>
             </a:lvl4pPr>
             <a:lvl5pPr>
+              <a:buNone/>
               <a:defRPr sz="1350" b="1">
                 <a:solidFill>
                   <a:srgbClr val="FFFFFF"/>
@@ -18943,6 +19047,7 @@
               </a:defRPr>
             </a:lvl5pPr>
             <a:lvl6pPr>
+              <a:buNone/>
               <a:defRPr sz="1350" b="1">
                 <a:solidFill>
                   <a:srgbClr val="FFFFFF"/>
@@ -18953,6 +19058,7 @@
               </a:defRPr>
             </a:lvl6pPr>
             <a:lvl7pPr>
+              <a:buNone/>
               <a:defRPr sz="1350" b="1">
                 <a:solidFill>
                   <a:srgbClr val="FFFFFF"/>
@@ -18963,6 +19069,7 @@
               </a:defRPr>
             </a:lvl7pPr>
             <a:lvl8pPr>
+              <a:buNone/>
               <a:defRPr sz="1350" b="1">
                 <a:solidFill>
                   <a:srgbClr val="FFFFFF"/>
@@ -18973,6 +19080,7 @@
               </a:defRPr>
             </a:lvl8pPr>
             <a:lvl9pPr>
+              <a:buNone/>
               <a:defRPr sz="1350" b="1">
                 <a:solidFill>
                   <a:srgbClr val="FFFFFF"/>
@@ -19129,6 +19237,7 @@
               </a:defRPr>
             </a:defPPr>
             <a:lvl1pPr>
+              <a:buNone/>
               <a:defRPr sz="1125" b="1">
                 <a:solidFill>
                   <a:srgbClr val="A9D4EA"/>
@@ -19139,6 +19248,7 @@
               </a:defRPr>
             </a:lvl1pPr>
             <a:lvl2pPr>
+              <a:buNone/>
               <a:defRPr sz="1125" b="1">
                 <a:solidFill>
                   <a:srgbClr val="A9D4EA"/>
@@ -19149,6 +19259,7 @@
               </a:defRPr>
             </a:lvl2pPr>
             <a:lvl3pPr>
+              <a:buNone/>
               <a:defRPr sz="1125" b="1">
                 <a:solidFill>
                   <a:srgbClr val="A9D4EA"/>
@@ -19159,6 +19270,7 @@
               </a:defRPr>
             </a:lvl3pPr>
             <a:lvl4pPr>
+              <a:buNone/>
               <a:defRPr sz="1125" b="1">
                 <a:solidFill>
                   <a:srgbClr val="A9D4EA"/>
@@ -19169,6 +19281,7 @@
               </a:defRPr>
             </a:lvl4pPr>
             <a:lvl5pPr>
+              <a:buNone/>
               <a:defRPr sz="1125" b="1">
                 <a:solidFill>
                   <a:srgbClr val="A9D4EA"/>
@@ -19179,6 +19292,7 @@
               </a:defRPr>
             </a:lvl5pPr>
             <a:lvl6pPr>
+              <a:buNone/>
               <a:defRPr sz="1125" b="1">
                 <a:solidFill>
                   <a:srgbClr val="A9D4EA"/>
@@ -19189,6 +19303,7 @@
               </a:defRPr>
             </a:lvl6pPr>
             <a:lvl7pPr>
+              <a:buNone/>
               <a:defRPr sz="1125" b="1">
                 <a:solidFill>
                   <a:srgbClr val="A9D4EA"/>
@@ -19199,6 +19314,7 @@
               </a:defRPr>
             </a:lvl7pPr>
             <a:lvl8pPr>
+              <a:buNone/>
               <a:defRPr sz="1125" b="1">
                 <a:solidFill>
                   <a:srgbClr val="A9D4EA"/>
@@ -19209,6 +19325,7 @@
               </a:defRPr>
             </a:lvl8pPr>
             <a:lvl9pPr>
+              <a:buNone/>
               <a:defRPr sz="1125" b="1">
                 <a:solidFill>
                   <a:srgbClr val="A9D4EA"/>
@@ -19305,6 +19422,7 @@
               </a:defRPr>
             </a:defPPr>
             <a:lvl1pPr>
+              <a:buNone/>
               <a:defRPr sz="1088" b="0">
                 <a:solidFill>
                   <a:srgbClr val="FFFFFF"/>
@@ -19315,6 +19433,7 @@
               </a:defRPr>
             </a:lvl1pPr>
             <a:lvl2pPr>
+              <a:buNone/>
               <a:defRPr sz="1088" b="0">
                 <a:solidFill>
                   <a:srgbClr val="FFFFFF"/>
@@ -19325,6 +19444,7 @@
               </a:defRPr>
             </a:lvl2pPr>
             <a:lvl3pPr>
+              <a:buNone/>
               <a:defRPr sz="1088" b="0">
                 <a:solidFill>
                   <a:srgbClr val="FFFFFF"/>
@@ -19335,6 +19455,7 @@
               </a:defRPr>
             </a:lvl3pPr>
             <a:lvl4pPr>
+              <a:buNone/>
               <a:defRPr sz="1088" b="0">
                 <a:solidFill>
                   <a:srgbClr val="FFFFFF"/>
@@ -19345,6 +19466,7 @@
               </a:defRPr>
             </a:lvl4pPr>
             <a:lvl5pPr>
+              <a:buNone/>
               <a:defRPr sz="1088" b="0">
                 <a:solidFill>
                   <a:srgbClr val="FFFFFF"/>
@@ -19355,6 +19477,7 @@
               </a:defRPr>
             </a:lvl5pPr>
             <a:lvl6pPr>
+              <a:buNone/>
               <a:defRPr sz="1088" b="0">
                 <a:solidFill>
                   <a:srgbClr val="FFFFFF"/>
@@ -19365,6 +19488,7 @@
               </a:defRPr>
             </a:lvl6pPr>
             <a:lvl7pPr>
+              <a:buNone/>
               <a:defRPr sz="1088" b="0">
                 <a:solidFill>
                   <a:srgbClr val="FFFFFF"/>
@@ -19375,6 +19499,7 @@
               </a:defRPr>
             </a:lvl7pPr>
             <a:lvl8pPr>
+              <a:buNone/>
               <a:defRPr sz="1088" b="0">
                 <a:solidFill>
                   <a:srgbClr val="FFFFFF"/>
@@ -19385,6 +19510,7 @@
               </a:defRPr>
             </a:lvl8pPr>
             <a:lvl9pPr>
+              <a:buNone/>
               <a:defRPr sz="1088" b="0">
                 <a:solidFill>
                   <a:srgbClr val="FFFFFF"/>
@@ -19571,6 +19697,7 @@
               </a:defRPr>
             </a:defPPr>
             <a:lvl1pPr algn="ctr">
+              <a:buNone/>
               <a:defRPr sz="1200" b="1">
                 <a:solidFill>
                   <a:srgbClr val="FFFFFF"/>
@@ -19581,6 +19708,7 @@
               </a:defRPr>
             </a:lvl1pPr>
             <a:lvl2pPr algn="ctr">
+              <a:buNone/>
               <a:defRPr sz="1200" b="1">
                 <a:solidFill>
                   <a:srgbClr val="FFFFFF"/>
@@ -19591,6 +19719,7 @@
               </a:defRPr>
             </a:lvl2pPr>
             <a:lvl3pPr algn="ctr">
+              <a:buNone/>
               <a:defRPr sz="1200" b="1">
                 <a:solidFill>
                   <a:srgbClr val="FFFFFF"/>
@@ -19601,6 +19730,7 @@
               </a:defRPr>
             </a:lvl3pPr>
             <a:lvl4pPr algn="ctr">
+              <a:buNone/>
               <a:defRPr sz="1200" b="1">
                 <a:solidFill>
                   <a:srgbClr val="FFFFFF"/>
@@ -19611,6 +19741,7 @@
               </a:defRPr>
             </a:lvl4pPr>
             <a:lvl5pPr algn="ctr">
+              <a:buNone/>
               <a:defRPr sz="1200" b="1">
                 <a:solidFill>
                   <a:srgbClr val="FFFFFF"/>
@@ -19621,6 +19752,7 @@
               </a:defRPr>
             </a:lvl5pPr>
             <a:lvl6pPr algn="ctr">
+              <a:buNone/>
               <a:defRPr sz="1200" b="1">
                 <a:solidFill>
                   <a:srgbClr val="FFFFFF"/>
@@ -19631,6 +19763,7 @@
               </a:defRPr>
             </a:lvl6pPr>
             <a:lvl7pPr algn="ctr">
+              <a:buNone/>
               <a:defRPr sz="1200" b="1">
                 <a:solidFill>
                   <a:srgbClr val="FFFFFF"/>
@@ -19641,6 +19774,7 @@
               </a:defRPr>
             </a:lvl7pPr>
             <a:lvl8pPr algn="ctr">
+              <a:buNone/>
               <a:defRPr sz="1200" b="1">
                 <a:solidFill>
                   <a:srgbClr val="FFFFFF"/>
@@ -19651,6 +19785,7 @@
               </a:defRPr>
             </a:lvl8pPr>
             <a:lvl9pPr algn="ctr">
+              <a:buNone/>
               <a:defRPr sz="1200" b="1">
                 <a:solidFill>
                   <a:srgbClr val="FFFFFF"/>
@@ -19740,6 +19875,7 @@
               </a:defRPr>
             </a:defPPr>
             <a:lvl1pPr>
+              <a:buNone/>
               <a:defRPr sz="1200">
                 <a:solidFill>
                   <a:srgbClr val="D8EBF7"/>
@@ -19750,6 +19886,7 @@
               </a:defRPr>
             </a:lvl1pPr>
             <a:lvl2pPr>
+              <a:buNone/>
               <a:defRPr sz="1200">
                 <a:solidFill>
                   <a:srgbClr val="D8EBF7"/>
@@ -19760,6 +19897,7 @@
               </a:defRPr>
             </a:lvl2pPr>
             <a:lvl3pPr>
+              <a:buNone/>
               <a:defRPr sz="1200">
                 <a:solidFill>
                   <a:srgbClr val="D8EBF7"/>
@@ -19770,6 +19908,7 @@
               </a:defRPr>
             </a:lvl3pPr>
             <a:lvl4pPr>
+              <a:buNone/>
               <a:defRPr sz="1200">
                 <a:solidFill>
                   <a:srgbClr val="D8EBF7"/>
@@ -19780,6 +19919,7 @@
               </a:defRPr>
             </a:lvl4pPr>
             <a:lvl5pPr>
+              <a:buNone/>
               <a:defRPr sz="1200">
                 <a:solidFill>
                   <a:srgbClr val="D8EBF7"/>
@@ -19790,6 +19930,7 @@
               </a:defRPr>
             </a:lvl5pPr>
             <a:lvl6pPr>
+              <a:buNone/>
               <a:defRPr sz="1200">
                 <a:solidFill>
                   <a:srgbClr val="D8EBF7"/>
@@ -19800,6 +19941,7 @@
               </a:defRPr>
             </a:lvl6pPr>
             <a:lvl7pPr>
+              <a:buNone/>
               <a:defRPr sz="1200">
                 <a:solidFill>
                   <a:srgbClr val="D8EBF7"/>
@@ -19810,6 +19952,7 @@
               </a:defRPr>
             </a:lvl7pPr>
             <a:lvl8pPr>
+              <a:buNone/>
               <a:defRPr sz="1200">
                 <a:solidFill>
                   <a:srgbClr val="D8EBF7"/>
@@ -19820,6 +19963,7 @@
               </a:defRPr>
             </a:lvl8pPr>
             <a:lvl9pPr>
+              <a:buNone/>
               <a:defRPr sz="1200">
                 <a:solidFill>
                   <a:srgbClr val="D8EBF7"/>
@@ -19832,6 +19976,7 @@
           </a:lstStyle>
           <a:p xmlns:a="http://schemas.openxmlformats.org/drawingml/2006/main">
             <a:pPr>
+              <a:buNone/>
               <a:defRPr sz="1200">
                 <a:solidFill>
                   <a:srgbClr val="D8EBF7"/>
@@ -19928,6 +20073,7 @@
               </a:defRPr>
             </a:defPPr>
             <a:lvl1pPr>
+              <a:buNone/>
               <a:defRPr sz="1200">
                 <a:solidFill>
                   <a:srgbClr val="D8EBF7"/>
@@ -19938,6 +20084,7 @@
               </a:defRPr>
             </a:lvl1pPr>
             <a:lvl2pPr>
+              <a:buNone/>
               <a:defRPr sz="1200">
                 <a:solidFill>
                   <a:srgbClr val="D8EBF7"/>
@@ -19948,6 +20095,7 @@
               </a:defRPr>
             </a:lvl2pPr>
             <a:lvl3pPr>
+              <a:buNone/>
               <a:defRPr sz="1200">
                 <a:solidFill>
                   <a:srgbClr val="D8EBF7"/>
@@ -19958,6 +20106,7 @@
               </a:defRPr>
             </a:lvl3pPr>
             <a:lvl4pPr>
+              <a:buNone/>
               <a:defRPr sz="1200">
                 <a:solidFill>
                   <a:srgbClr val="D8EBF7"/>
@@ -19968,6 +20117,7 @@
               </a:defRPr>
             </a:lvl4pPr>
             <a:lvl5pPr>
+              <a:buNone/>
               <a:defRPr sz="1200">
                 <a:solidFill>
                   <a:srgbClr val="D8EBF7"/>
@@ -19978,6 +20128,7 @@
               </a:defRPr>
             </a:lvl5pPr>
             <a:lvl6pPr>
+              <a:buNone/>
               <a:defRPr sz="1200">
                 <a:solidFill>
                   <a:srgbClr val="D8EBF7"/>
@@ -19988,6 +20139,7 @@
               </a:defRPr>
             </a:lvl6pPr>
             <a:lvl7pPr>
+              <a:buNone/>
               <a:defRPr sz="1200">
                 <a:solidFill>
                   <a:srgbClr val="D8EBF7"/>
@@ -19998,6 +20150,7 @@
               </a:defRPr>
             </a:lvl7pPr>
             <a:lvl8pPr>
+              <a:buNone/>
               <a:defRPr sz="1200">
                 <a:solidFill>
                   <a:srgbClr val="D8EBF7"/>
@@ -20008,6 +20161,7 @@
               </a:defRPr>
             </a:lvl8pPr>
             <a:lvl9pPr>
+              <a:buNone/>
               <a:defRPr sz="1200">
                 <a:solidFill>
                   <a:srgbClr val="D8EBF7"/>
@@ -20020,6 +20174,7 @@
           </a:lstStyle>
           <a:p xmlns:a="http://schemas.openxmlformats.org/drawingml/2006/main">
             <a:pPr>
+              <a:buNone/>
               <a:defRPr sz="1200">
                 <a:solidFill>
                   <a:srgbClr val="D8EBF7"/>
@@ -20116,6 +20271,7 @@
               </a:defRPr>
             </a:defPPr>
             <a:lvl1pPr>
+              <a:buNone/>
               <a:defRPr sz="1200">
                 <a:solidFill>
                   <a:srgbClr val="D8EBF7"/>
@@ -20126,6 +20282,7 @@
               </a:defRPr>
             </a:lvl1pPr>
             <a:lvl2pPr>
+              <a:buNone/>
               <a:defRPr sz="1200">
                 <a:solidFill>
                   <a:srgbClr val="D8EBF7"/>
@@ -20136,6 +20293,7 @@
               </a:defRPr>
             </a:lvl2pPr>
             <a:lvl3pPr>
+              <a:buNone/>
               <a:defRPr sz="1200">
                 <a:solidFill>
                   <a:srgbClr val="D8EBF7"/>
@@ -20146,6 +20304,7 @@
               </a:defRPr>
             </a:lvl3pPr>
             <a:lvl4pPr>
+              <a:buNone/>
               <a:defRPr sz="1200">
                 <a:solidFill>
                   <a:srgbClr val="D8EBF7"/>
@@ -20156,6 +20315,7 @@
               </a:defRPr>
             </a:lvl4pPr>
             <a:lvl5pPr>
+              <a:buNone/>
               <a:defRPr sz="1200">
                 <a:solidFill>
                   <a:srgbClr val="D8EBF7"/>
@@ -20166,6 +20326,7 @@
               </a:defRPr>
             </a:lvl5pPr>
             <a:lvl6pPr>
+              <a:buNone/>
               <a:defRPr sz="1200">
                 <a:solidFill>
                   <a:srgbClr val="D8EBF7"/>
@@ -20176,6 +20337,7 @@
               </a:defRPr>
             </a:lvl6pPr>
             <a:lvl7pPr>
+              <a:buNone/>
               <a:defRPr sz="1200">
                 <a:solidFill>
                   <a:srgbClr val="D8EBF7"/>
@@ -20186,6 +20348,7 @@
               </a:defRPr>
             </a:lvl7pPr>
             <a:lvl8pPr>
+              <a:buNone/>
               <a:defRPr sz="1200">
                 <a:solidFill>
                   <a:srgbClr val="D8EBF7"/>
@@ -20196,6 +20359,7 @@
               </a:defRPr>
             </a:lvl8pPr>
             <a:lvl9pPr>
+              <a:buNone/>
               <a:defRPr sz="1200">
                 <a:solidFill>
                   <a:srgbClr val="D8EBF7"/>
@@ -20208,6 +20372,7 @@
           </a:lstStyle>
           <a:p xmlns:a="http://schemas.openxmlformats.org/drawingml/2006/main">
             <a:pPr>
+              <a:buNone/>
               <a:defRPr sz="1200">
                 <a:solidFill>
                   <a:srgbClr val="D8EBF7"/>
@@ -20304,6 +20469,7 @@
               </a:defRPr>
             </a:defPPr>
             <a:lvl1pPr>
+              <a:buNone/>
               <a:defRPr sz="1200">
                 <a:solidFill>
                   <a:srgbClr val="D8EBF7"/>
@@ -20314,6 +20480,7 @@
               </a:defRPr>
             </a:lvl1pPr>
             <a:lvl2pPr>
+              <a:buNone/>
               <a:defRPr sz="1200">
                 <a:solidFill>
                   <a:srgbClr val="D8EBF7"/>
@@ -20324,6 +20491,7 @@
               </a:defRPr>
             </a:lvl2pPr>
             <a:lvl3pPr>
+              <a:buNone/>
               <a:defRPr sz="1200">
                 <a:solidFill>
                   <a:srgbClr val="D8EBF7"/>
@@ -20334,6 +20502,7 @@
               </a:defRPr>
             </a:lvl3pPr>
             <a:lvl4pPr>
+              <a:buNone/>
               <a:defRPr sz="1200">
                 <a:solidFill>
                   <a:srgbClr val="D8EBF7"/>
@@ -20344,6 +20513,7 @@
               </a:defRPr>
             </a:lvl4pPr>
             <a:lvl5pPr>
+              <a:buNone/>
               <a:defRPr sz="1200">
                 <a:solidFill>
                   <a:srgbClr val="D8EBF7"/>
@@ -20354,6 +20524,7 @@
               </a:defRPr>
             </a:lvl5pPr>
             <a:lvl6pPr>
+              <a:buNone/>
               <a:defRPr sz="1200">
                 <a:solidFill>
                   <a:srgbClr val="D8EBF7"/>
@@ -20364,6 +20535,7 @@
               </a:defRPr>
             </a:lvl6pPr>
             <a:lvl7pPr>
+              <a:buNone/>
               <a:defRPr sz="1200">
                 <a:solidFill>
                   <a:srgbClr val="D8EBF7"/>
@@ -20374,6 +20546,7 @@
               </a:defRPr>
             </a:lvl7pPr>
             <a:lvl8pPr>
+              <a:buNone/>
               <a:defRPr sz="1200">
                 <a:solidFill>
                   <a:srgbClr val="D8EBF7"/>
@@ -20384,6 +20557,7 @@
               </a:defRPr>
             </a:lvl8pPr>
             <a:lvl9pPr>
+              <a:buNone/>
               <a:defRPr sz="1200">
                 <a:solidFill>
                   <a:srgbClr val="D8EBF7"/>
@@ -20396,6 +20570,7 @@
           </a:lstStyle>
           <a:p xmlns:a="http://schemas.openxmlformats.org/drawingml/2006/main">
             <a:pPr>
+              <a:buNone/>
               <a:defRPr sz="1200">
                 <a:solidFill>
                   <a:srgbClr val="D8EBF7"/>
@@ -20492,6 +20667,7 @@
               </a:defRPr>
             </a:defPPr>
             <a:lvl1pPr>
+              <a:buNone/>
               <a:defRPr sz="1200">
                 <a:solidFill>
                   <a:srgbClr val="D8EBF7"/>
@@ -20502,6 +20678,7 @@
               </a:defRPr>
             </a:lvl1pPr>
             <a:lvl2pPr>
+              <a:buNone/>
               <a:defRPr sz="1200">
                 <a:solidFill>
                   <a:srgbClr val="D8EBF7"/>
@@ -20512,6 +20689,7 @@
               </a:defRPr>
             </a:lvl2pPr>
             <a:lvl3pPr>
+              <a:buNone/>
               <a:defRPr sz="1200">
                 <a:solidFill>
                   <a:srgbClr val="D8EBF7"/>
@@ -20522,6 +20700,7 @@
               </a:defRPr>
             </a:lvl3pPr>
             <a:lvl4pPr>
+              <a:buNone/>
               <a:defRPr sz="1200">
                 <a:solidFill>
                   <a:srgbClr val="D8EBF7"/>
@@ -20532,6 +20711,7 @@
               </a:defRPr>
             </a:lvl4pPr>
             <a:lvl5pPr>
+              <a:buNone/>
               <a:defRPr sz="1200">
                 <a:solidFill>
                   <a:srgbClr val="D8EBF7"/>
@@ -20542,6 +20722,7 @@
               </a:defRPr>
             </a:lvl5pPr>
             <a:lvl6pPr>
+              <a:buNone/>
               <a:defRPr sz="1200">
                 <a:solidFill>
                   <a:srgbClr val="D8EBF7"/>
@@ -20552,6 +20733,7 @@
               </a:defRPr>
             </a:lvl6pPr>
             <a:lvl7pPr>
+              <a:buNone/>
               <a:defRPr sz="1200">
                 <a:solidFill>
                   <a:srgbClr val="D8EBF7"/>
@@ -20562,6 +20744,7 @@
               </a:defRPr>
             </a:lvl7pPr>
             <a:lvl8pPr>
+              <a:buNone/>
               <a:defRPr sz="1200">
                 <a:solidFill>
                   <a:srgbClr val="D8EBF7"/>
@@ -20572,6 +20755,7 @@
               </a:defRPr>
             </a:lvl8pPr>
             <a:lvl9pPr>
+              <a:buNone/>
               <a:defRPr sz="1200">
                 <a:solidFill>
                   <a:srgbClr val="D8EBF7"/>
@@ -20584,6 +20768,7 @@
           </a:lstStyle>
           <a:p xmlns:a="http://schemas.openxmlformats.org/drawingml/2006/main">
             <a:pPr>
+              <a:buNone/>
               <a:defRPr sz="1200">
                 <a:solidFill>
                   <a:srgbClr val="D8EBF7"/>
@@ -20649,6 +20834,7 @@
               </a:defRPr>
             </a:defPPr>
             <a:lvl1pPr>
+              <a:buNone/>
               <a:defRPr sz="1425" b="1">
                 <a:solidFill>
                   <a:srgbClr val="53C4D5"/>
@@ -20659,6 +20845,7 @@
               </a:defRPr>
             </a:lvl1pPr>
             <a:lvl2pPr>
+              <a:buNone/>
               <a:defRPr sz="1425" b="1">
                 <a:solidFill>
                   <a:srgbClr val="53C4D5"/>
@@ -20669,6 +20856,7 @@
               </a:defRPr>
             </a:lvl2pPr>
             <a:lvl3pPr>
+              <a:buNone/>
               <a:defRPr sz="1425" b="1">
                 <a:solidFill>
                   <a:srgbClr val="53C4D5"/>
@@ -20679,6 +20867,7 @@
               </a:defRPr>
             </a:lvl3pPr>
             <a:lvl4pPr>
+              <a:buNone/>
               <a:defRPr sz="1425" b="1">
                 <a:solidFill>
                   <a:srgbClr val="53C4D5"/>
@@ -20689,6 +20878,7 @@
               </a:defRPr>
             </a:lvl4pPr>
             <a:lvl5pPr>
+              <a:buNone/>
               <a:defRPr sz="1425" b="1">
                 <a:solidFill>
                   <a:srgbClr val="53C4D5"/>
@@ -20699,6 +20889,7 @@
               </a:defRPr>
             </a:lvl5pPr>
             <a:lvl6pPr>
+              <a:buNone/>
               <a:defRPr sz="1425" b="1">
                 <a:solidFill>
                   <a:srgbClr val="53C4D5"/>
@@ -20709,6 +20900,7 @@
               </a:defRPr>
             </a:lvl6pPr>
             <a:lvl7pPr>
+              <a:buNone/>
               <a:defRPr sz="1425" b="1">
                 <a:solidFill>
                   <a:srgbClr val="53C4D5"/>
@@ -20719,6 +20911,7 @@
               </a:defRPr>
             </a:lvl7pPr>
             <a:lvl8pPr>
+              <a:buNone/>
               <a:defRPr sz="1425" b="1">
                 <a:solidFill>
                   <a:srgbClr val="53C4D5"/>
@@ -20729,6 +20922,7 @@
               </a:defRPr>
             </a:lvl8pPr>
             <a:lvl9pPr>
+              <a:buNone/>
               <a:defRPr sz="1425" b="1">
                 <a:solidFill>
                   <a:srgbClr val="53C4D5"/>
@@ -20741,6 +20935,7 @@
           </a:lstStyle>
           <a:p xmlns:a="http://schemas.openxmlformats.org/drawingml/2006/main">
             <a:pPr>
+              <a:buNone/>
               <a:defRPr sz="1425" b="1">
                 <a:solidFill>
                   <a:srgbClr val="53C4D5"/>
@@ -20806,6 +21001,7 @@
               </a:defRPr>
             </a:defPPr>
             <a:lvl1pPr>
+              <a:buNone/>
               <a:defRPr sz="1350" b="1">
                 <a:solidFill>
                   <a:srgbClr val="FFFFFF"/>
@@ -20816,6 +21012,7 @@
               </a:defRPr>
             </a:lvl1pPr>
             <a:lvl2pPr>
+              <a:buNone/>
               <a:defRPr sz="1350" b="1">
                 <a:solidFill>
                   <a:srgbClr val="FFFFFF"/>
@@ -20826,6 +21023,7 @@
               </a:defRPr>
             </a:lvl2pPr>
             <a:lvl3pPr>
+              <a:buNone/>
               <a:defRPr sz="1350" b="1">
                 <a:solidFill>
                   <a:srgbClr val="FFFFFF"/>
@@ -20836,6 +21034,7 @@
               </a:defRPr>
             </a:lvl3pPr>
             <a:lvl4pPr>
+              <a:buNone/>
               <a:defRPr sz="1350" b="1">
                 <a:solidFill>
                   <a:srgbClr val="FFFFFF"/>
@@ -20846,6 +21045,7 @@
               </a:defRPr>
             </a:lvl4pPr>
             <a:lvl5pPr>
+              <a:buNone/>
               <a:defRPr sz="1350" b="1">
                 <a:solidFill>
                   <a:srgbClr val="FFFFFF"/>
@@ -20856,6 +21056,7 @@
               </a:defRPr>
             </a:lvl5pPr>
             <a:lvl6pPr>
+              <a:buNone/>
               <a:defRPr sz="1350" b="1">
                 <a:solidFill>
                   <a:srgbClr val="FFFFFF"/>
@@ -20866,6 +21067,7 @@
               </a:defRPr>
             </a:lvl6pPr>
             <a:lvl7pPr>
+              <a:buNone/>
               <a:defRPr sz="1350" b="1">
                 <a:solidFill>
                   <a:srgbClr val="FFFFFF"/>
@@ -20876,6 +21078,7 @@
               </a:defRPr>
             </a:lvl7pPr>
             <a:lvl8pPr>
+              <a:buNone/>
               <a:defRPr sz="1350" b="1">
                 <a:solidFill>
                   <a:srgbClr val="FFFFFF"/>
@@ -20886,6 +21089,7 @@
               </a:defRPr>
             </a:lvl8pPr>
             <a:lvl9pPr>
+              <a:buNone/>
               <a:defRPr sz="1350" b="1">
                 <a:solidFill>
                   <a:srgbClr val="FFFFFF"/>
@@ -20898,6 +21102,7 @@
           </a:lstStyle>
           <a:p xmlns:a="http://schemas.openxmlformats.org/drawingml/2006/main">
             <a:pPr>
+              <a:buNone/>
               <a:defRPr sz="1350" b="1">
                 <a:solidFill>
                   <a:srgbClr val="FFFFFF"/>
@@ -20963,6 +21168,7 @@
               </a:defRPr>
             </a:defPPr>
             <a:lvl1pPr>
+              <a:buNone/>
               <a:defRPr sz="1425" b="1">
                 <a:solidFill>
                   <a:srgbClr val="53C4D5"/>
@@ -20973,6 +21179,7 @@
               </a:defRPr>
             </a:lvl1pPr>
             <a:lvl2pPr>
+              <a:buNone/>
               <a:defRPr sz="1425" b="1">
                 <a:solidFill>
                   <a:srgbClr val="53C4D5"/>
@@ -20983,6 +21190,7 @@
               </a:defRPr>
             </a:lvl2pPr>
             <a:lvl3pPr>
+              <a:buNone/>
               <a:defRPr sz="1425" b="1">
                 <a:solidFill>
                   <a:srgbClr val="53C4D5"/>
@@ -20993,6 +21201,7 @@
               </a:defRPr>
             </a:lvl3pPr>
             <a:lvl4pPr>
+              <a:buNone/>
               <a:defRPr sz="1425" b="1">
                 <a:solidFill>
                   <a:srgbClr val="53C4D5"/>
@@ -21003,6 +21212,7 @@
               </a:defRPr>
             </a:lvl4pPr>
             <a:lvl5pPr>
+              <a:buNone/>
               <a:defRPr sz="1425" b="1">
                 <a:solidFill>
                   <a:srgbClr val="53C4D5"/>
@@ -21013,6 +21223,7 @@
               </a:defRPr>
             </a:lvl5pPr>
             <a:lvl6pPr>
+              <a:buNone/>
               <a:defRPr sz="1425" b="1">
                 <a:solidFill>
                   <a:srgbClr val="53C4D5"/>
@@ -21023,6 +21234,7 @@
               </a:defRPr>
             </a:lvl6pPr>
             <a:lvl7pPr>
+              <a:buNone/>
               <a:defRPr sz="1425" b="1">
                 <a:solidFill>
                   <a:srgbClr val="53C4D5"/>
@@ -21033,6 +21245,7 @@
               </a:defRPr>
             </a:lvl7pPr>
             <a:lvl8pPr>
+              <a:buNone/>
               <a:defRPr sz="1425" b="1">
                 <a:solidFill>
                   <a:srgbClr val="53C4D5"/>
@@ -21043,6 +21256,7 @@
               </a:defRPr>
             </a:lvl8pPr>
             <a:lvl9pPr>
+              <a:buNone/>
               <a:defRPr sz="1425" b="1">
                 <a:solidFill>
                   <a:srgbClr val="53C4D5"/>
@@ -21055,6 +21269,7 @@
           </a:lstStyle>
           <a:p xmlns:a="http://schemas.openxmlformats.org/drawingml/2006/main">
             <a:pPr>
+              <a:buNone/>
               <a:defRPr sz="1425" b="1">
                 <a:solidFill>
                   <a:srgbClr val="53C4D5"/>
@@ -21120,6 +21335,7 @@
               </a:defRPr>
             </a:defPPr>
             <a:lvl1pPr>
+              <a:buNone/>
               <a:defRPr sz="1350" b="1">
                 <a:solidFill>
                   <a:srgbClr val="FFFFFF"/>
@@ -21130,6 +21346,7 @@
               </a:defRPr>
             </a:lvl1pPr>
             <a:lvl2pPr>
+              <a:buNone/>
               <a:defRPr sz="1350" b="1">
                 <a:solidFill>
                   <a:srgbClr val="FFFFFF"/>
@@ -21140,6 +21357,7 @@
               </a:defRPr>
             </a:lvl2pPr>
             <a:lvl3pPr>
+              <a:buNone/>
               <a:defRPr sz="1350" b="1">
                 <a:solidFill>
                   <a:srgbClr val="FFFFFF"/>
@@ -21150,6 +21368,7 @@
               </a:defRPr>
             </a:lvl3pPr>
             <a:lvl4pPr>
+              <a:buNone/>
               <a:defRPr sz="1350" b="1">
                 <a:solidFill>
                   <a:srgbClr val="FFFFFF"/>
@@ -21160,6 +21379,7 @@
               </a:defRPr>
             </a:lvl4pPr>
             <a:lvl5pPr>
+              <a:buNone/>
               <a:defRPr sz="1350" b="1">
                 <a:solidFill>
                   <a:srgbClr val="FFFFFF"/>
@@ -21170,6 +21390,7 @@
               </a:defRPr>
             </a:lvl5pPr>
             <a:lvl6pPr>
+              <a:buNone/>
               <a:defRPr sz="1350" b="1">
                 <a:solidFill>
                   <a:srgbClr val="FFFFFF"/>
@@ -21180,6 +21401,7 @@
               </a:defRPr>
             </a:lvl6pPr>
             <a:lvl7pPr>
+              <a:buNone/>
               <a:defRPr sz="1350" b="1">
                 <a:solidFill>
                   <a:srgbClr val="FFFFFF"/>
@@ -21190,6 +21412,7 @@
               </a:defRPr>
             </a:lvl7pPr>
             <a:lvl8pPr>
+              <a:buNone/>
               <a:defRPr sz="1350" b="1">
                 <a:solidFill>
                   <a:srgbClr val="FFFFFF"/>
@@ -21200,6 +21423,7 @@
               </a:defRPr>
             </a:lvl8pPr>
             <a:lvl9pPr>
+              <a:buNone/>
               <a:defRPr sz="1350" b="1">
                 <a:solidFill>
                   <a:srgbClr val="FFFFFF"/>
@@ -21212,6 +21436,7 @@
           </a:lstStyle>
           <a:p xmlns:a="http://schemas.openxmlformats.org/drawingml/2006/main">
             <a:pPr>
+              <a:buNone/>
               <a:defRPr sz="1350" b="1">
                 <a:solidFill>
                   <a:srgbClr val="FFFFFF"/>
@@ -21448,7 +21673,7 @@
           <p:cNvPr id="22" name="">
             <a:extLst xmlns:a="http://schemas.openxmlformats.org/drawingml/2006/main">
               <a:ext uri="{FF2B5EF4-FFF2-40B4-BE49-F238E27FC236}">
-                <a16:creationId xmlns:a16="http://schemas.microsoft.com/office/drawing/2014/main" id="{5647BF2E-9602-43F6-8177-F05D4C7A1DB0}"/>
+                <a16:creationId xmlns:a16="http://schemas.microsoft.com/office/drawing/2014/main" id="{DFFE41BF-9E2A-4701-A128-0156EF084332}"/>
               </a:ext>
             </a:extLst>
           </p:cNvPr>
@@ -21458,7 +21683,7 @@
           <p:nvPr/>
         </p:nvPicPr>
         <p:blipFill>
-          <a:blip xmlns:r="http://schemas.openxmlformats.org/officeDocument/2006/relationships" xmlns:a="http://schemas.openxmlformats.org/drawingml/2006/main" r:embed="R8d654b20744048e6"/>
+          <a:blip xmlns:r="http://schemas.openxmlformats.org/officeDocument/2006/relationships" xmlns:a="http://schemas.openxmlformats.org/drawingml/2006/main" r:embed="Re025e10cf1114d93"/>
           <a:srcRect xmlns:a="http://schemas.openxmlformats.org/drawingml/2006/main" l="0" t="10054" r="0" b="10054"/>
           <a:stretch xmlns:a="http://schemas.openxmlformats.org/drawingml/2006/main"/>
         </p:blipFill>
@@ -22618,7 +22843,7 @@
           <p:cNvPr id="39" name="">
             <a:extLst xmlns:a="http://schemas.openxmlformats.org/drawingml/2006/main">
               <a:ext uri="{FF2B5EF4-FFF2-40B4-BE49-F238E27FC236}">
-                <a16:creationId xmlns:a16="http://schemas.microsoft.com/office/drawing/2014/main" id="{D7ED766E-B98C-49AD-ABDC-D551F808E348}"/>
+                <a16:creationId xmlns:a16="http://schemas.microsoft.com/office/drawing/2014/main" id="{50A9E1C5-4100-4377-92AA-E975BB6C5AA6}"/>
               </a:ext>
             </a:extLst>
           </p:cNvPr>
@@ -22628,7 +22853,7 @@
           <p:nvPr/>
         </p:nvPicPr>
         <p:blipFill>
-          <a:blip xmlns:r="http://schemas.openxmlformats.org/officeDocument/2006/relationships" xmlns:a="http://schemas.openxmlformats.org/drawingml/2006/main" r:embed="Red0b9cdeed824174"/>
+          <a:blip xmlns:r="http://schemas.openxmlformats.org/officeDocument/2006/relationships" xmlns:a="http://schemas.openxmlformats.org/drawingml/2006/main" r:embed="Rd1795dcef732411f"/>
           <a:srcRect xmlns:a="http://schemas.openxmlformats.org/drawingml/2006/main" l="0" t="10054" r="0" b="10054"/>
           <a:stretch xmlns:a="http://schemas.openxmlformats.org/drawingml/2006/main"/>
         </p:blipFill>
@@ -24330,7 +24555,7 @@
           <p:cNvPr id="64" name="">
             <a:extLst xmlns:a="http://schemas.openxmlformats.org/drawingml/2006/main">
               <a:ext uri="{FF2B5EF4-FFF2-40B4-BE49-F238E27FC236}">
-                <a16:creationId xmlns:a16="http://schemas.microsoft.com/office/drawing/2014/main" id="{79477BAF-B074-44D4-89D7-4669BC3A5E3F}"/>
+                <a16:creationId xmlns:a16="http://schemas.microsoft.com/office/drawing/2014/main" id="{6CDBD6B0-9B83-4D1E-AF20-57F98B37C013}"/>
               </a:ext>
             </a:extLst>
           </p:cNvPr>
@@ -24340,7 +24565,7 @@
           <p:nvPr/>
         </p:nvPicPr>
         <p:blipFill>
-          <a:blip xmlns:r="http://schemas.openxmlformats.org/officeDocument/2006/relationships" xmlns:a="http://schemas.openxmlformats.org/drawingml/2006/main" r:embed="Rad771b175cdd48ae"/>
+          <a:blip xmlns:r="http://schemas.openxmlformats.org/officeDocument/2006/relationships" xmlns:a="http://schemas.openxmlformats.org/drawingml/2006/main" r:embed="Rc7684f1a8d7b4f7a"/>
           <a:srcRect xmlns:a="http://schemas.openxmlformats.org/drawingml/2006/main" l="0" t="10054" r="0" b="10054"/>
           <a:stretch xmlns:a="http://schemas.openxmlformats.org/drawingml/2006/main"/>
         </p:blipFill>
@@ -25666,7 +25891,7 @@
           <p:cNvPr id="84" name="">
             <a:extLst xmlns:a="http://schemas.openxmlformats.org/drawingml/2006/main">
               <a:ext uri="{FF2B5EF4-FFF2-40B4-BE49-F238E27FC236}">
-                <a16:creationId xmlns:a16="http://schemas.microsoft.com/office/drawing/2014/main" id="{C4325034-461B-4D71-8184-271AA3F5861F}"/>
+                <a16:creationId xmlns:a16="http://schemas.microsoft.com/office/drawing/2014/main" id="{C88FB47D-ADA5-40C5-8BCA-48631ACC6615}"/>
               </a:ext>
             </a:extLst>
           </p:cNvPr>
@@ -25676,7 +25901,7 @@
           <p:nvPr/>
         </p:nvPicPr>
         <p:blipFill>
-          <a:blip xmlns:r="http://schemas.openxmlformats.org/officeDocument/2006/relationships" xmlns:a="http://schemas.openxmlformats.org/drawingml/2006/main" r:embed="R10bdc481347643b6"/>
+          <a:blip xmlns:r="http://schemas.openxmlformats.org/officeDocument/2006/relationships" xmlns:a="http://schemas.openxmlformats.org/drawingml/2006/main" r:embed="R26cb5dd81b594f9b"/>
           <a:srcRect xmlns:a="http://schemas.openxmlformats.org/drawingml/2006/main" l="0" t="10054" r="0" b="10054"/>
           <a:stretch xmlns:a="http://schemas.openxmlformats.org/drawingml/2006/main"/>
         </p:blipFill>
@@ -26997,7 +27222,7 @@
           <p:cNvPr id="105" name="">
             <a:extLst xmlns:a="http://schemas.openxmlformats.org/drawingml/2006/main">
               <a:ext uri="{FF2B5EF4-FFF2-40B4-BE49-F238E27FC236}">
-                <a16:creationId xmlns:a16="http://schemas.microsoft.com/office/drawing/2014/main" id="{BCC32E1B-275D-46B0-BCB2-4E1497832EAD}"/>
+                <a16:creationId xmlns:a16="http://schemas.microsoft.com/office/drawing/2014/main" id="{165FFD5C-689D-47A6-9DAC-230D4CF89F0D}"/>
               </a:ext>
             </a:extLst>
           </p:cNvPr>
@@ -27007,7 +27232,7 @@
           <p:nvPr/>
         </p:nvPicPr>
         <p:blipFill>
-          <a:blip xmlns:r="http://schemas.openxmlformats.org/officeDocument/2006/relationships" xmlns:a="http://schemas.openxmlformats.org/drawingml/2006/main" r:embed="R72ce49ec030f458a"/>
+          <a:blip xmlns:r="http://schemas.openxmlformats.org/officeDocument/2006/relationships" xmlns:a="http://schemas.openxmlformats.org/drawingml/2006/main" r:embed="Ref4250944b974785"/>
           <a:srcRect xmlns:a="http://schemas.openxmlformats.org/drawingml/2006/main" l="0" t="10054" r="0" b="10054"/>
           <a:stretch xmlns:a="http://schemas.openxmlformats.org/drawingml/2006/main"/>
         </p:blipFill>
@@ -28699,7 +28924,7 @@
           <p:cNvPr id="132" name="">
             <a:extLst xmlns:a="http://schemas.openxmlformats.org/drawingml/2006/main">
               <a:ext uri="{FF2B5EF4-FFF2-40B4-BE49-F238E27FC236}">
-                <a16:creationId xmlns:a16="http://schemas.microsoft.com/office/drawing/2014/main" id="{1A671746-88B6-4280-858F-30EDBD21EA9F}"/>
+                <a16:creationId xmlns:a16="http://schemas.microsoft.com/office/drawing/2014/main" id="{8A24936E-25D4-4EF1-853C-91E5506A8B6A}"/>
               </a:ext>
             </a:extLst>
           </p:cNvPr>
@@ -28709,7 +28934,7 @@
           <p:nvPr/>
         </p:nvPicPr>
         <p:blipFill>
-          <a:blip xmlns:r="http://schemas.openxmlformats.org/officeDocument/2006/relationships" xmlns:a="http://schemas.openxmlformats.org/drawingml/2006/main" r:embed="R6434ed8eca8e4a0b"/>
+          <a:blip xmlns:r="http://schemas.openxmlformats.org/officeDocument/2006/relationships" xmlns:a="http://schemas.openxmlformats.org/drawingml/2006/main" r:embed="Rc5c2a6c9bc8d4475"/>
           <a:srcRect xmlns:a="http://schemas.openxmlformats.org/drawingml/2006/main" l="0" t="10054" r="0" b="10054"/>
           <a:stretch xmlns:a="http://schemas.openxmlformats.org/drawingml/2006/main"/>
         </p:blipFill>
@@ -30765,7 +30990,7 @@
           <p:cNvPr id="163" name="">
             <a:extLst xmlns:a="http://schemas.openxmlformats.org/drawingml/2006/main">
               <a:ext uri="{FF2B5EF4-FFF2-40B4-BE49-F238E27FC236}">
-                <a16:creationId xmlns:a16="http://schemas.microsoft.com/office/drawing/2014/main" id="{E3BE1F1B-A3C7-4EBC-9D1B-784FE22DEFE4}"/>
+                <a16:creationId xmlns:a16="http://schemas.microsoft.com/office/drawing/2014/main" id="{C2AFDC82-D39F-4CF6-953F-64A0973262C1}"/>
               </a:ext>
             </a:extLst>
           </p:cNvPr>
@@ -30775,7 +31000,7 @@
           <p:nvPr/>
         </p:nvPicPr>
         <p:blipFill>
-          <a:blip xmlns:r="http://schemas.openxmlformats.org/officeDocument/2006/relationships" xmlns:a="http://schemas.openxmlformats.org/drawingml/2006/main" r:embed="Rb15567b2a48647f9"/>
+          <a:blip xmlns:r="http://schemas.openxmlformats.org/officeDocument/2006/relationships" xmlns:a="http://schemas.openxmlformats.org/drawingml/2006/main" r:embed="Rf33fe2d44fa34a58"/>
           <a:srcRect xmlns:a="http://schemas.openxmlformats.org/drawingml/2006/main" l="0" t="10054" r="0" b="10054"/>
           <a:stretch xmlns:a="http://schemas.openxmlformats.org/drawingml/2006/main"/>
         </p:blipFill>
@@ -31838,7 +32063,7 @@
           <p:cNvPr id="178" name="">
             <a:extLst xmlns:a="http://schemas.openxmlformats.org/drawingml/2006/main">
               <a:ext uri="{FF2B5EF4-FFF2-40B4-BE49-F238E27FC236}">
-                <a16:creationId xmlns:a16="http://schemas.microsoft.com/office/drawing/2014/main" id="{48ED4CAB-2FE9-44AF-B7DA-64D82D1259C1}"/>
+                <a16:creationId xmlns:a16="http://schemas.microsoft.com/office/drawing/2014/main" id="{AC103B16-AE42-4A8A-B866-11031351B31B}"/>
               </a:ext>
             </a:extLst>
           </p:cNvPr>
@@ -31848,7 +32073,7 @@
           <p:nvPr/>
         </p:nvPicPr>
         <p:blipFill>
-          <a:blip xmlns:r="http://schemas.openxmlformats.org/officeDocument/2006/relationships" xmlns:a="http://schemas.openxmlformats.org/drawingml/2006/main" r:embed="R8dc8407d8c7f4ccb"/>
+          <a:blip xmlns:r="http://schemas.openxmlformats.org/officeDocument/2006/relationships" xmlns:a="http://schemas.openxmlformats.org/drawingml/2006/main" r:embed="R02b55ac8f8b94ed1"/>
           <a:srcRect xmlns:a="http://schemas.openxmlformats.org/drawingml/2006/main" l="0" t="10054" r="0" b="10054"/>
           <a:stretch xmlns:a="http://schemas.openxmlformats.org/drawingml/2006/main"/>
         </p:blipFill>

</xml_diff>